<commit_message>
Publish editable six-slide presentation and PDF
</commit_message>
<xml_diff>
--- a/submission/HimanshuDigitalTwin_Presentation.pptx
+++ b/submission/HimanshuDigitalTwin_Presentation.pptx
@@ -7231,7 +7231,7 @@
               </a:defRPr>
             </a:pPr>
             <a:r>
-              <a:t>03 / DEMONSTRATION</a:t>
+              <a:t>03 / WORKING PROTOTYPE</a:t>
             </a:r>
           </a:p>
         </p:txBody>
@@ -7270,7 +7270,7 @@
               </a:defRPr>
             </a:pPr>
             <a:r>
-              <a:t>Six checkpoints. One reproducible synthetic patient.</a:t>
+              <a:t>The running demo — not just an architecture diagram.</a:t>
             </a:r>
           </a:p>
         </p:txBody>
@@ -7309,7 +7309,7 @@
               </a:defRPr>
             </a:pPr>
             <a:r>
-              <a:t>The default FastAPI dashboard lets judges jump directly to each state.</a:t>
+              <a:t>Actual FastAPI dashboard, reproducible synthetic lunch checkpoint.</a:t>
             </a:r>
           </a:p>
         </p:txBody>
@@ -7435,8 +7435,8 @@
         </p:nvSpPr>
         <p:spPr>
           <a:xfrm>
-            <a:off x="603504" y="2240280"/>
-            <a:ext cx="3584448" cy="1261872"/>
+            <a:off x="566928" y="2221992"/>
+            <a:ext cx="7808975" cy="3858768"/>
           </a:xfrm>
           <a:prstGeom prst="roundRect">
             <a:avLst>
@@ -7474,22 +7474,87 @@
           </a:p>
         </p:txBody>
       </p:sp>
-      <p:sp>
-        <p:nvSpPr>
-          <p:cNvPr id="11" name="Rectangle 10"/>
+      <p:pic>
+        <p:nvPicPr>
+          <p:cNvPr id="11" name="Picture 10" descr="Live_Demo_Lunch.png"/>
+          <p:cNvPicPr>
+            <a:picLocks noChangeAspect="1"/>
+          </p:cNvPicPr>
+          <p:nvPr/>
+        </p:nvPicPr>
+        <p:blipFill>
+          <a:blip r:embed="rId2"/>
+          <a:stretch>
+            <a:fillRect/>
+          </a:stretch>
+        </p:blipFill>
+        <p:spPr>
+          <a:xfrm>
+            <a:off x="676656" y="2331720"/>
+            <a:ext cx="7580375" cy="3429000"/>
+          </a:xfrm>
+          <a:prstGeom prst="rect">
+            <a:avLst/>
+          </a:prstGeom>
+        </p:spPr>
+      </p:pic>
+      <p:sp>
+        <p:nvSpPr>
+          <p:cNvPr id="12" name="TextBox 11"/>
+          <p:cNvSpPr txBox="1"/>
+          <p:nvPr/>
+        </p:nvSpPr>
+        <p:spPr>
+          <a:xfrm>
+            <a:off x="777240" y="5797296"/>
+            <a:ext cx="7296912" cy="201168"/>
+          </a:xfrm>
+          <a:prstGeom prst="rect">
+            <a:avLst/>
+          </a:prstGeom>
+          <a:noFill/>
+        </p:spPr>
+        <p:txBody>
+          <a:bodyPr wrap="square" lIns="0" rIns="0" tIns="0" bIns="0" anchor="ctr">
+            <a:spAutoFit/>
+          </a:bodyPr>
+          <a:lstStyle/>
+          <a:p>
+            <a:pPr algn="l">
+              <a:spcAft>
+                <a:spcPts val="200"/>
+              </a:spcAft>
+              <a:defRPr sz="1000" b="1">
+                <a:solidFill>
+                  <a:srgbClr val="167E78"/>
+                </a:solidFill>
+                <a:latin typeface="Aptos"/>
+              </a:defRPr>
+            </a:pPr>
+            <a:r>
+              <a:t>ACTUAL LOCAL DEMO   /   LUNCH CHECKPOINT</a:t>
+            </a:r>
+          </a:p>
+        </p:txBody>
+      </p:sp>
+      <p:sp>
+        <p:nvSpPr>
+          <p:cNvPr id="13" name="Rounded Rectangle 12"/>
           <p:cNvSpPr/>
           <p:nvPr/>
         </p:nvSpPr>
         <p:spPr>
           <a:xfrm>
-            <a:off x="603504" y="2240280"/>
-            <a:ext cx="50292" cy="1261872"/>
-          </a:xfrm>
-          <a:prstGeom prst="rect">
-            <a:avLst/>
+            <a:off x="8558784" y="2221992"/>
+            <a:ext cx="3035808" cy="3858768"/>
+          </a:xfrm>
+          <a:prstGeom prst="roundRect">
+            <a:avLst>
+              <a:gd name="adj" fmla="val 15000"/>
+            </a:avLst>
           </a:prstGeom>
           <a:solidFill>
-            <a:srgbClr val="167E78"/>
+            <a:srgbClr val="E5F0EE"/>
           </a:solidFill>
           <a:ln>
             <a:noFill/>
@@ -7519,31 +7584,31 @@
       </p:sp>
       <p:sp>
         <p:nvSpPr>
-          <p:cNvPr id="12" name="TextBox 11"/>
-          <p:cNvSpPr txBox="1"/>
-          <p:nvPr/>
-        </p:nvSpPr>
-        <p:spPr>
-          <a:xfrm>
-            <a:off x="804672" y="2395728"/>
-            <a:ext cx="502920" cy="365760"/>
-          </a:xfrm>
-          <a:prstGeom prst="rect">
-            <a:avLst/>
-          </a:prstGeom>
-          <a:noFill/>
-        </p:spPr>
-        <p:txBody>
-          <a:bodyPr wrap="square" lIns="0" rIns="0" tIns="0" bIns="0" anchor="ctr">
-            <a:spAutoFit/>
-          </a:bodyPr>
-          <a:lstStyle/>
-          <a:p>
-            <a:pPr algn="l">
-              <a:spcAft>
-                <a:spcPts val="200"/>
-              </a:spcAft>
-              <a:defRPr sz="2300" b="1">
+          <p:cNvPr id="14" name="TextBox 13"/>
+          <p:cNvSpPr txBox="1"/>
+          <p:nvPr/>
+        </p:nvSpPr>
+        <p:spPr>
+          <a:xfrm>
+            <a:off x="8805672" y="2459736"/>
+            <a:ext cx="2514600" cy="237744"/>
+          </a:xfrm>
+          <a:prstGeom prst="rect">
+            <a:avLst/>
+          </a:prstGeom>
+          <a:noFill/>
+        </p:spPr>
+        <p:txBody>
+          <a:bodyPr wrap="square" lIns="0" rIns="0" tIns="0" bIns="0" anchor="ctr">
+            <a:spAutoFit/>
+          </a:bodyPr>
+          <a:lstStyle/>
+          <a:p>
+            <a:pPr algn="l">
+              <a:spcAft>
+                <a:spcPts val="200"/>
+              </a:spcAft>
+              <a:defRPr sz="1200" b="1">
                 <a:solidFill>
                   <a:srgbClr val="167E78"/>
                 </a:solidFill>
@@ -7551,38 +7616,38 @@
               </a:defRPr>
             </a:pPr>
             <a:r>
-              <a:t>01</a:t>
-            </a:r>
-          </a:p>
-        </p:txBody>
-      </p:sp>
-      <p:sp>
-        <p:nvSpPr>
-          <p:cNvPr id="13" name="TextBox 12"/>
-          <p:cNvSpPr txBox="1"/>
-          <p:nvPr/>
-        </p:nvSpPr>
-        <p:spPr>
-          <a:xfrm>
-            <a:off x="1362456" y="2377440"/>
-            <a:ext cx="2596896" cy="338328"/>
-          </a:xfrm>
-          <a:prstGeom prst="rect">
-            <a:avLst/>
-          </a:prstGeom>
-          <a:noFill/>
-        </p:spPr>
-        <p:txBody>
-          <a:bodyPr wrap="square" lIns="0" rIns="0" tIns="0" bIns="0" anchor="ctr">
-            <a:spAutoFit/>
-          </a:bodyPr>
-          <a:lstStyle/>
-          <a:p>
-            <a:pPr algn="l">
-              <a:spcAft>
-                <a:spcPts val="200"/>
-              </a:spcAft>
-              <a:defRPr sz="1600" b="1">
+              <a:t>JUDGE PATH</a:t>
+            </a:r>
+          </a:p>
+        </p:txBody>
+      </p:sp>
+      <p:sp>
+        <p:nvSpPr>
+          <p:cNvPr id="15" name="TextBox 14"/>
+          <p:cNvSpPr txBox="1"/>
+          <p:nvPr/>
+        </p:nvSpPr>
+        <p:spPr>
+          <a:xfrm>
+            <a:off x="8805672" y="2834640"/>
+            <a:ext cx="2560320" cy="210312"/>
+          </a:xfrm>
+          <a:prstGeom prst="rect">
+            <a:avLst/>
+          </a:prstGeom>
+          <a:noFill/>
+        </p:spPr>
+        <p:txBody>
+          <a:bodyPr wrap="square" lIns="0" rIns="0" tIns="0" bIns="0" anchor="ctr">
+            <a:spAutoFit/>
+          </a:bodyPr>
+          <a:lstStyle/>
+          <a:p>
+            <a:pPr algn="l">
+              <a:spcAft>
+                <a:spcPts val="200"/>
+              </a:spcAft>
+              <a:defRPr sz="1400" b="1">
                 <a:solidFill>
                   <a:srgbClr val="172F3B"/>
                 </a:solidFill>
@@ -7590,38 +7655,38 @@
               </a:defRPr>
             </a:pPr>
             <a:r>
-              <a:t>BASELINE</a:t>
-            </a:r>
-          </a:p>
-        </p:txBody>
-      </p:sp>
-      <p:sp>
-        <p:nvSpPr>
-          <p:cNvPr id="14" name="TextBox 13"/>
-          <p:cNvSpPr txBox="1"/>
-          <p:nvPr/>
-        </p:nvSpPr>
-        <p:spPr>
-          <a:xfrm>
-            <a:off x="1371600" y="2807208"/>
-            <a:ext cx="2633472" cy="320040"/>
-          </a:xfrm>
-          <a:prstGeom prst="rect">
-            <a:avLst/>
-          </a:prstGeom>
-          <a:noFill/>
-        </p:spPr>
-        <p:txBody>
-          <a:bodyPr wrap="square" lIns="0" rIns="0" tIns="0" bIns="0" anchor="ctr">
-            <a:spAutoFit/>
-          </a:bodyPr>
-          <a:lstStyle/>
-          <a:p>
-            <a:pPr algn="l">
-              <a:spcAft>
-                <a:spcPts val="200"/>
-              </a:spcAft>
-              <a:defRPr sz="1300" b="0">
+              <a:t>01 · Baseline</a:t>
+            </a:r>
+          </a:p>
+        </p:txBody>
+      </p:sp>
+      <p:sp>
+        <p:nvSpPr>
+          <p:cNvPr id="16" name="TextBox 15"/>
+          <p:cNvSpPr txBox="1"/>
+          <p:nvPr/>
+        </p:nvSpPr>
+        <p:spPr>
+          <a:xfrm>
+            <a:off x="8805672" y="3035808"/>
+            <a:ext cx="2560320" cy="182880"/>
+          </a:xfrm>
+          <a:prstGeom prst="rect">
+            <a:avLst/>
+          </a:prstGeom>
+          <a:noFill/>
+        </p:spPr>
+        <p:txBody>
+          <a:bodyPr wrap="square" lIns="0" rIns="0" tIns="0" bIns="0" anchor="ctr">
+            <a:spAutoFit/>
+          </a:bodyPr>
+          <a:lstStyle/>
+          <a:p>
+            <a:pPr algn="l">
+              <a:spcAft>
+                <a:spcPts val="200"/>
+              </a:spcAft>
+              <a:defRPr sz="1000" b="0">
                 <a:solidFill>
                   <a:srgbClr val="667D88"/>
                 </a:solidFill>
@@ -7629,98 +7694,8 @@
               </a:defRPr>
             </a:pPr>
             <a:r>
-              <a:t>Profile + first valid CGM</a:t>
-            </a:r>
-          </a:p>
-        </p:txBody>
-      </p:sp>
-      <p:sp>
-        <p:nvSpPr>
-          <p:cNvPr id="15" name="Rounded Rectangle 14"/>
-          <p:cNvSpPr/>
-          <p:nvPr/>
-        </p:nvSpPr>
-        <p:spPr>
-          <a:xfrm>
-            <a:off x="4425696" y="2240280"/>
-            <a:ext cx="3584448" cy="1261872"/>
-          </a:xfrm>
-          <a:prstGeom prst="roundRect">
-            <a:avLst>
-              <a:gd name="adj" fmla="val 15000"/>
-            </a:avLst>
-          </a:prstGeom>
-          <a:solidFill>
-            <a:srgbClr val="FFFFFF"/>
-          </a:solidFill>
-          <a:ln w="12700">
-            <a:solidFill>
-              <a:srgbClr val="D9E4E6"/>
-            </a:solidFill>
-          </a:ln>
-        </p:spPr>
-        <p:style>
-          <a:lnRef idx="1">
-            <a:schemeClr val="accent1"/>
-          </a:lnRef>
-          <a:fillRef idx="3">
-            <a:schemeClr val="accent1"/>
-          </a:fillRef>
-          <a:effectRef idx="2">
-            <a:schemeClr val="accent1"/>
-          </a:effectRef>
-          <a:fontRef idx="minor">
-            <a:schemeClr val="lt1"/>
-          </a:fontRef>
-        </p:style>
-        <p:txBody>
-          <a:bodyPr rtlCol="0" anchor="ctr"/>
-          <a:lstStyle/>
-          <a:p>
-            <a:pPr algn="ctr"/>
-          </a:p>
-        </p:txBody>
-      </p:sp>
-      <p:sp>
-        <p:nvSpPr>
-          <p:cNvPr id="16" name="Rectangle 15"/>
-          <p:cNvSpPr/>
-          <p:nvPr/>
-        </p:nvSpPr>
-        <p:spPr>
-          <a:xfrm>
-            <a:off x="4425696" y="2240280"/>
-            <a:ext cx="50292" cy="1261872"/>
-          </a:xfrm>
-          <a:prstGeom prst="rect">
-            <a:avLst/>
-          </a:prstGeom>
-          <a:solidFill>
-            <a:srgbClr val="167E78"/>
-          </a:solidFill>
-          <a:ln>
-            <a:noFill/>
-          </a:ln>
-        </p:spPr>
-        <p:style>
-          <a:lnRef idx="1">
-            <a:schemeClr val="accent1"/>
-          </a:lnRef>
-          <a:fillRef idx="3">
-            <a:schemeClr val="accent1"/>
-          </a:fillRef>
-          <a:effectRef idx="2">
-            <a:schemeClr val="accent1"/>
-          </a:effectRef>
-          <a:fontRef idx="minor">
-            <a:schemeClr val="lt1"/>
-          </a:fontRef>
-        </p:style>
-        <p:txBody>
-          <a:bodyPr rtlCol="0" anchor="ctr"/>
-          <a:lstStyle/>
-          <a:p>
-            <a:pPr algn="ctr"/>
+              <a:t>Initial reading</a:t>
+            </a:r>
           </a:p>
         </p:txBody>
       </p:sp>
@@ -7732,33 +7707,33 @@
         </p:nvSpPr>
         <p:spPr>
           <a:xfrm>
-            <a:off x="4626864" y="2395728"/>
-            <a:ext cx="502920" cy="365760"/>
-          </a:xfrm>
-          <a:prstGeom prst="rect">
-            <a:avLst/>
-          </a:prstGeom>
-          <a:noFill/>
-        </p:spPr>
-        <p:txBody>
-          <a:bodyPr wrap="square" lIns="0" rIns="0" tIns="0" bIns="0" anchor="ctr">
-            <a:spAutoFit/>
-          </a:bodyPr>
-          <a:lstStyle/>
-          <a:p>
-            <a:pPr algn="l">
-              <a:spcAft>
-                <a:spcPts val="200"/>
-              </a:spcAft>
-              <a:defRPr sz="2300" b="1">
-                <a:solidFill>
-                  <a:srgbClr val="167E78"/>
-                </a:solidFill>
-                <a:latin typeface="Aptos"/>
-              </a:defRPr>
-            </a:pPr>
-            <a:r>
-              <a:t>02</a:t>
+            <a:off x="8805672" y="3282696"/>
+            <a:ext cx="2560320" cy="210312"/>
+          </a:xfrm>
+          <a:prstGeom prst="rect">
+            <a:avLst/>
+          </a:prstGeom>
+          <a:noFill/>
+        </p:spPr>
+        <p:txBody>
+          <a:bodyPr wrap="square" lIns="0" rIns="0" tIns="0" bIns="0" anchor="ctr">
+            <a:spAutoFit/>
+          </a:bodyPr>
+          <a:lstStyle/>
+          <a:p>
+            <a:pPr algn="l">
+              <a:spcAft>
+                <a:spcPts val="200"/>
+              </a:spcAft>
+              <a:defRPr sz="1400" b="1">
+                <a:solidFill>
+                  <a:srgbClr val="172F3B"/>
+                </a:solidFill>
+                <a:latin typeface="Aptos"/>
+              </a:defRPr>
+            </a:pPr>
+            <a:r>
+              <a:t>02 · Breakfast</a:t>
             </a:r>
           </a:p>
         </p:txBody>
@@ -7771,25 +7746,64 @@
         </p:nvSpPr>
         <p:spPr>
           <a:xfrm>
-            <a:off x="5184648" y="2377440"/>
-            <a:ext cx="2596896" cy="338328"/>
-          </a:xfrm>
-          <a:prstGeom prst="rect">
-            <a:avLst/>
-          </a:prstGeom>
-          <a:noFill/>
-        </p:spPr>
-        <p:txBody>
-          <a:bodyPr wrap="square" lIns="0" rIns="0" tIns="0" bIns="0" anchor="ctr">
-            <a:spAutoFit/>
-          </a:bodyPr>
-          <a:lstStyle/>
-          <a:p>
-            <a:pPr algn="l">
-              <a:spcAft>
-                <a:spcPts val="200"/>
-              </a:spcAft>
-              <a:defRPr sz="1600" b="1">
+            <a:off x="8805672" y="3483864"/>
+            <a:ext cx="2560320" cy="182880"/>
+          </a:xfrm>
+          <a:prstGeom prst="rect">
+            <a:avLst/>
+          </a:prstGeom>
+          <a:noFill/>
+        </p:spPr>
+        <p:txBody>
+          <a:bodyPr wrap="square" lIns="0" rIns="0" tIns="0" bIns="0" anchor="ctr">
+            <a:spAutoFit/>
+          </a:bodyPr>
+          <a:lstStyle/>
+          <a:p>
+            <a:pPr algn="l">
+              <a:spcAft>
+                <a:spcPts val="200"/>
+              </a:spcAft>
+              <a:defRPr sz="1000" b="0">
+                <a:solidFill>
+                  <a:srgbClr val="667D88"/>
+                </a:solidFill>
+                <a:latin typeface="Aptos"/>
+              </a:defRPr>
+            </a:pPr>
+            <a:r>
+              <a:t>Meal context</a:t>
+            </a:r>
+          </a:p>
+        </p:txBody>
+      </p:sp>
+      <p:sp>
+        <p:nvSpPr>
+          <p:cNvPr id="19" name="TextBox 18"/>
+          <p:cNvSpPr txBox="1"/>
+          <p:nvPr/>
+        </p:nvSpPr>
+        <p:spPr>
+          <a:xfrm>
+            <a:off x="8805672" y="3730752"/>
+            <a:ext cx="2560320" cy="210312"/>
+          </a:xfrm>
+          <a:prstGeom prst="rect">
+            <a:avLst/>
+          </a:prstGeom>
+          <a:noFill/>
+        </p:spPr>
+        <p:txBody>
+          <a:bodyPr wrap="square" lIns="0" rIns="0" tIns="0" bIns="0" anchor="ctr">
+            <a:spAutoFit/>
+          </a:bodyPr>
+          <a:lstStyle/>
+          <a:p>
+            <a:pPr algn="l">
+              <a:spcAft>
+                <a:spcPts val="200"/>
+              </a:spcAft>
+              <a:defRPr sz="1400" b="1">
                 <a:solidFill>
                   <a:srgbClr val="172F3B"/>
                 </a:solidFill>
@@ -7797,38 +7811,38 @@
               </a:defRPr>
             </a:pPr>
             <a:r>
-              <a:t>BREAKFAST</a:t>
-            </a:r>
-          </a:p>
-        </p:txBody>
-      </p:sp>
-      <p:sp>
-        <p:nvSpPr>
-          <p:cNvPr id="19" name="TextBox 18"/>
-          <p:cNvSpPr txBox="1"/>
-          <p:nvPr/>
-        </p:nvSpPr>
-        <p:spPr>
-          <a:xfrm>
-            <a:off x="5193792" y="2807208"/>
-            <a:ext cx="2633472" cy="320040"/>
-          </a:xfrm>
-          <a:prstGeom prst="rect">
-            <a:avLst/>
-          </a:prstGeom>
-          <a:noFill/>
-        </p:spPr>
-        <p:txBody>
-          <a:bodyPr wrap="square" lIns="0" rIns="0" tIns="0" bIns="0" anchor="ctr">
-            <a:spAutoFit/>
-          </a:bodyPr>
-          <a:lstStyle/>
-          <a:p>
-            <a:pPr algn="l">
-              <a:spcAft>
-                <a:spcPts val="200"/>
-              </a:spcAft>
-              <a:defRPr sz="1300" b="0">
+              <a:t>03 · Lunch</a:t>
+            </a:r>
+          </a:p>
+        </p:txBody>
+      </p:sp>
+      <p:sp>
+        <p:nvSpPr>
+          <p:cNvPr id="20" name="TextBox 19"/>
+          <p:cNvSpPr txBox="1"/>
+          <p:nvPr/>
+        </p:nvSpPr>
+        <p:spPr>
+          <a:xfrm>
+            <a:off x="8805672" y="3931920"/>
+            <a:ext cx="2560320" cy="182880"/>
+          </a:xfrm>
+          <a:prstGeom prst="rect">
+            <a:avLst/>
+          </a:prstGeom>
+          <a:noFill/>
+        </p:spPr>
+        <p:txBody>
+          <a:bodyPr wrap="square" lIns="0" rIns="0" tIns="0" bIns="0" anchor="ctr">
+            <a:spAutoFit/>
+          </a:bodyPr>
+          <a:lstStyle/>
+          <a:p>
+            <a:pPr algn="l">
+              <a:spcAft>
+                <a:spcPts val="200"/>
+              </a:spcAft>
+              <a:defRPr sz="1000" b="0">
                 <a:solidFill>
                   <a:srgbClr val="667D88"/>
                 </a:solidFill>
@@ -7836,98 +7850,47 @@
               </a:defRPr>
             </a:pPr>
             <a:r>
-              <a:t>Meal context changes</a:t>
-            </a:r>
-          </a:p>
-        </p:txBody>
-      </p:sp>
-      <p:sp>
-        <p:nvSpPr>
-          <p:cNvPr id="20" name="Rounded Rectangle 19"/>
-          <p:cNvSpPr/>
-          <p:nvPr/>
-        </p:nvSpPr>
-        <p:spPr>
-          <a:xfrm>
-            <a:off x="8247888" y="2240280"/>
-            <a:ext cx="3584448" cy="1261872"/>
-          </a:xfrm>
-          <a:prstGeom prst="roundRect">
-            <a:avLst>
-              <a:gd name="adj" fmla="val 15000"/>
-            </a:avLst>
-          </a:prstGeom>
-          <a:solidFill>
-            <a:srgbClr val="FFFFFF"/>
-          </a:solidFill>
-          <a:ln w="12700">
-            <a:solidFill>
-              <a:srgbClr val="D9E4E6"/>
-            </a:solidFill>
-          </a:ln>
-        </p:spPr>
-        <p:style>
-          <a:lnRef idx="1">
-            <a:schemeClr val="accent1"/>
-          </a:lnRef>
-          <a:fillRef idx="3">
-            <a:schemeClr val="accent1"/>
-          </a:fillRef>
-          <a:effectRef idx="2">
-            <a:schemeClr val="accent1"/>
-          </a:effectRef>
-          <a:fontRef idx="minor">
-            <a:schemeClr val="lt1"/>
-          </a:fontRef>
-        </p:style>
-        <p:txBody>
-          <a:bodyPr rtlCol="0" anchor="ctr"/>
-          <a:lstStyle/>
-          <a:p>
-            <a:pPr algn="ctr"/>
-          </a:p>
-        </p:txBody>
-      </p:sp>
-      <p:sp>
-        <p:nvSpPr>
-          <p:cNvPr id="21" name="Rectangle 20"/>
-          <p:cNvSpPr/>
-          <p:nvPr/>
-        </p:nvSpPr>
-        <p:spPr>
-          <a:xfrm>
-            <a:off x="8247888" y="2240280"/>
-            <a:ext cx="50292" cy="1261872"/>
-          </a:xfrm>
-          <a:prstGeom prst="rect">
-            <a:avLst/>
-          </a:prstGeom>
-          <a:solidFill>
-            <a:srgbClr val="167E78"/>
-          </a:solidFill>
-          <a:ln>
-            <a:noFill/>
-          </a:ln>
-        </p:spPr>
-        <p:style>
-          <a:lnRef idx="1">
-            <a:schemeClr val="accent1"/>
-          </a:lnRef>
-          <a:fillRef idx="3">
-            <a:schemeClr val="accent1"/>
-          </a:fillRef>
-          <a:effectRef idx="2">
-            <a:schemeClr val="accent1"/>
-          </a:effectRef>
-          <a:fontRef idx="minor">
-            <a:schemeClr val="lt1"/>
-          </a:fontRef>
-        </p:style>
-        <p:txBody>
-          <a:bodyPr rtlCol="0" anchor="ctr"/>
-          <a:lstStyle/>
-          <a:p>
-            <a:pPr algn="ctr"/>
+              <a:t>Forecast trajectory</a:t>
+            </a:r>
+          </a:p>
+        </p:txBody>
+      </p:sp>
+      <p:sp>
+        <p:nvSpPr>
+          <p:cNvPr id="21" name="TextBox 20"/>
+          <p:cNvSpPr txBox="1"/>
+          <p:nvPr/>
+        </p:nvSpPr>
+        <p:spPr>
+          <a:xfrm>
+            <a:off x="8805672" y="4178808"/>
+            <a:ext cx="2560320" cy="210312"/>
+          </a:xfrm>
+          <a:prstGeom prst="rect">
+            <a:avLst/>
+          </a:prstGeom>
+          <a:noFill/>
+        </p:spPr>
+        <p:txBody>
+          <a:bodyPr wrap="square" lIns="0" rIns="0" tIns="0" bIns="0" anchor="ctr">
+            <a:spAutoFit/>
+          </a:bodyPr>
+          <a:lstStyle/>
+          <a:p>
+            <a:pPr algn="l">
+              <a:spcAft>
+                <a:spcPts val="200"/>
+              </a:spcAft>
+              <a:defRPr sz="1400" b="1">
+                <a:solidFill>
+                  <a:srgbClr val="172F3B"/>
+                </a:solidFill>
+                <a:latin typeface="Aptos"/>
+              </a:defRPr>
+            </a:pPr>
+            <a:r>
+              <a:t>04 · Verification</a:t>
+            </a:r>
           </a:p>
         </p:txBody>
       </p:sp>
@@ -7939,33 +7902,33 @@
         </p:nvSpPr>
         <p:spPr>
           <a:xfrm>
-            <a:off x="8449056" y="2395728"/>
-            <a:ext cx="502920" cy="365760"/>
-          </a:xfrm>
-          <a:prstGeom prst="rect">
-            <a:avLst/>
-          </a:prstGeom>
-          <a:noFill/>
-        </p:spPr>
-        <p:txBody>
-          <a:bodyPr wrap="square" lIns="0" rIns="0" tIns="0" bIns="0" anchor="ctr">
-            <a:spAutoFit/>
-          </a:bodyPr>
-          <a:lstStyle/>
-          <a:p>
-            <a:pPr algn="l">
-              <a:spcAft>
-                <a:spcPts val="200"/>
-              </a:spcAft>
-              <a:defRPr sz="2300" b="1">
-                <a:solidFill>
-                  <a:srgbClr val="167E78"/>
-                </a:solidFill>
-                <a:latin typeface="Aptos"/>
-              </a:defRPr>
-            </a:pPr>
-            <a:r>
-              <a:t>03</a:t>
+            <a:off x="8805672" y="4379976"/>
+            <a:ext cx="2560320" cy="182880"/>
+          </a:xfrm>
+          <a:prstGeom prst="rect">
+            <a:avLst/>
+          </a:prstGeom>
+          <a:noFill/>
+        </p:spPr>
+        <p:txBody>
+          <a:bodyPr wrap="square" lIns="0" rIns="0" tIns="0" bIns="0" anchor="ctr">
+            <a:spAutoFit/>
+          </a:bodyPr>
+          <a:lstStyle/>
+          <a:p>
+            <a:pPr algn="l">
+              <a:spcAft>
+                <a:spcPts val="200"/>
+              </a:spcAft>
+              <a:defRPr sz="1000" b="0">
+                <a:solidFill>
+                  <a:srgbClr val="667D88"/>
+                </a:solidFill>
+                <a:latin typeface="Aptos"/>
+              </a:defRPr>
+            </a:pPr>
+            <a:r>
+              <a:t>Forecasts resolved</a:t>
             </a:r>
           </a:p>
         </p:txBody>
@@ -7978,25 +7941,25 @@
         </p:nvSpPr>
         <p:spPr>
           <a:xfrm>
-            <a:off x="9006840" y="2377440"/>
-            <a:ext cx="2596896" cy="338328"/>
-          </a:xfrm>
-          <a:prstGeom prst="rect">
-            <a:avLst/>
-          </a:prstGeom>
-          <a:noFill/>
-        </p:spPr>
-        <p:txBody>
-          <a:bodyPr wrap="square" lIns="0" rIns="0" tIns="0" bIns="0" anchor="ctr">
-            <a:spAutoFit/>
-          </a:bodyPr>
-          <a:lstStyle/>
-          <a:p>
-            <a:pPr algn="l">
-              <a:spcAft>
-                <a:spcPts val="200"/>
-              </a:spcAft>
-              <a:defRPr sz="1600" b="1">
+            <a:off x="8805672" y="4626864"/>
+            <a:ext cx="2560320" cy="210312"/>
+          </a:xfrm>
+          <a:prstGeom prst="rect">
+            <a:avLst/>
+          </a:prstGeom>
+          <a:noFill/>
+        </p:spPr>
+        <p:txBody>
+          <a:bodyPr wrap="square" lIns="0" rIns="0" tIns="0" bIns="0" anchor="ctr">
+            <a:spAutoFit/>
+          </a:bodyPr>
+          <a:lstStyle/>
+          <a:p>
+            <a:pPr algn="l">
+              <a:spcAft>
+                <a:spcPts val="200"/>
+              </a:spcAft>
+              <a:defRPr sz="1400" b="1">
                 <a:solidFill>
                   <a:srgbClr val="172F3B"/>
                 </a:solidFill>
@@ -8004,7 +7967,7 @@
               </a:defRPr>
             </a:pPr>
             <a:r>
-              <a:t>LUNCH</a:t>
+              <a:t>05 · Sensor gap</a:t>
             </a:r>
           </a:p>
         </p:txBody>
@@ -8017,25 +7980,25 @@
         </p:nvSpPr>
         <p:spPr>
           <a:xfrm>
-            <a:off x="9015984" y="2807208"/>
-            <a:ext cx="2633472" cy="320040"/>
-          </a:xfrm>
-          <a:prstGeom prst="rect">
-            <a:avLst/>
-          </a:prstGeom>
-          <a:noFill/>
-        </p:spPr>
-        <p:txBody>
-          <a:bodyPr wrap="square" lIns="0" rIns="0" tIns="0" bIns="0" anchor="ctr">
-            <a:spAutoFit/>
-          </a:bodyPr>
-          <a:lstStyle/>
-          <a:p>
-            <a:pPr algn="l">
-              <a:spcAft>
-                <a:spcPts val="200"/>
-              </a:spcAft>
-              <a:defRPr sz="1300" b="0">
+            <a:off x="8805672" y="4828032"/>
+            <a:ext cx="2560320" cy="182880"/>
+          </a:xfrm>
+          <a:prstGeom prst="rect">
+            <a:avLst/>
+          </a:prstGeom>
+          <a:noFill/>
+        </p:spPr>
+        <p:txBody>
+          <a:bodyPr wrap="square" lIns="0" rIns="0" tIns="0" bIns="0" anchor="ctr">
+            <a:spAutoFit/>
+          </a:bodyPr>
+          <a:lstStyle/>
+          <a:p>
+            <a:pPr algn="l">
+              <a:spcAft>
+                <a:spcPts val="200"/>
+              </a:spcAft>
+              <a:defRPr sz="1000" b="0">
                 <a:solidFill>
                   <a:srgbClr val="667D88"/>
                 </a:solidFill>
@@ -8043,98 +8006,86 @@
               </a:defRPr>
             </a:pPr>
             <a:r>
-              <a:t>Forecast trajectory</a:t>
-            </a:r>
-          </a:p>
-        </p:txBody>
-      </p:sp>
-      <p:sp>
-        <p:nvSpPr>
-          <p:cNvPr id="25" name="Rounded Rectangle 24"/>
-          <p:cNvSpPr/>
-          <p:nvPr/>
-        </p:nvSpPr>
-        <p:spPr>
-          <a:xfrm>
-            <a:off x="603504" y="3694176"/>
-            <a:ext cx="3584448" cy="1261872"/>
-          </a:xfrm>
-          <a:prstGeom prst="roundRect">
-            <a:avLst>
-              <a:gd name="adj" fmla="val 15000"/>
-            </a:avLst>
-          </a:prstGeom>
-          <a:solidFill>
-            <a:srgbClr val="FFFFFF"/>
-          </a:solidFill>
-          <a:ln w="12700">
-            <a:solidFill>
-              <a:srgbClr val="D9E4E6"/>
-            </a:solidFill>
-          </a:ln>
-        </p:spPr>
-        <p:style>
-          <a:lnRef idx="1">
-            <a:schemeClr val="accent1"/>
-          </a:lnRef>
-          <a:fillRef idx="3">
-            <a:schemeClr val="accent1"/>
-          </a:fillRef>
-          <a:effectRef idx="2">
-            <a:schemeClr val="accent1"/>
-          </a:effectRef>
-          <a:fontRef idx="minor">
-            <a:schemeClr val="lt1"/>
-          </a:fontRef>
-        </p:style>
-        <p:txBody>
-          <a:bodyPr rtlCol="0" anchor="ctr"/>
-          <a:lstStyle/>
-          <a:p>
-            <a:pPr algn="ctr"/>
-          </a:p>
-        </p:txBody>
-      </p:sp>
-      <p:sp>
-        <p:nvSpPr>
-          <p:cNvPr id="26" name="Rectangle 25"/>
-          <p:cNvSpPr/>
-          <p:nvPr/>
-        </p:nvSpPr>
-        <p:spPr>
-          <a:xfrm>
-            <a:off x="603504" y="3694176"/>
-            <a:ext cx="50292" cy="1261872"/>
-          </a:xfrm>
-          <a:prstGeom prst="rect">
-            <a:avLst/>
-          </a:prstGeom>
-          <a:solidFill>
-            <a:srgbClr val="167E78"/>
-          </a:solidFill>
-          <a:ln>
-            <a:noFill/>
-          </a:ln>
-        </p:spPr>
-        <p:style>
-          <a:lnRef idx="1">
-            <a:schemeClr val="accent1"/>
-          </a:lnRef>
-          <a:fillRef idx="3">
-            <a:schemeClr val="accent1"/>
-          </a:fillRef>
-          <a:effectRef idx="2">
-            <a:schemeClr val="accent1"/>
-          </a:effectRef>
-          <a:fontRef idx="minor">
-            <a:schemeClr val="lt1"/>
-          </a:fontRef>
-        </p:style>
-        <p:txBody>
-          <a:bodyPr rtlCol="0" anchor="ctr"/>
-          <a:lstStyle/>
-          <a:p>
-            <a:pPr algn="ctr"/>
+              <a:t>Forecast withheld</a:t>
+            </a:r>
+          </a:p>
+        </p:txBody>
+      </p:sp>
+      <p:sp>
+        <p:nvSpPr>
+          <p:cNvPr id="25" name="TextBox 24"/>
+          <p:cNvSpPr txBox="1"/>
+          <p:nvPr/>
+        </p:nvSpPr>
+        <p:spPr>
+          <a:xfrm>
+            <a:off x="8805672" y="5074920"/>
+            <a:ext cx="2560320" cy="210312"/>
+          </a:xfrm>
+          <a:prstGeom prst="rect">
+            <a:avLst/>
+          </a:prstGeom>
+          <a:noFill/>
+        </p:spPr>
+        <p:txBody>
+          <a:bodyPr wrap="square" lIns="0" rIns="0" tIns="0" bIns="0" anchor="ctr">
+            <a:spAutoFit/>
+          </a:bodyPr>
+          <a:lstStyle/>
+          <a:p>
+            <a:pPr algn="l">
+              <a:spcAft>
+                <a:spcPts val="200"/>
+              </a:spcAft>
+              <a:defRPr sz="1400" b="1">
+                <a:solidFill>
+                  <a:srgbClr val="172F3B"/>
+                </a:solidFill>
+                <a:latin typeface="Aptos"/>
+              </a:defRPr>
+            </a:pPr>
+            <a:r>
+              <a:t>06 · Recovery</a:t>
+            </a:r>
+          </a:p>
+        </p:txBody>
+      </p:sp>
+      <p:sp>
+        <p:nvSpPr>
+          <p:cNvPr id="26" name="TextBox 25"/>
+          <p:cNvSpPr txBox="1"/>
+          <p:nvPr/>
+        </p:nvSpPr>
+        <p:spPr>
+          <a:xfrm>
+            <a:off x="8805672" y="5276088"/>
+            <a:ext cx="2560320" cy="182880"/>
+          </a:xfrm>
+          <a:prstGeom prst="rect">
+            <a:avLst/>
+          </a:prstGeom>
+          <a:noFill/>
+        </p:spPr>
+        <p:txBody>
+          <a:bodyPr wrap="square" lIns="0" rIns="0" tIns="0" bIns="0" anchor="ctr">
+            <a:spAutoFit/>
+          </a:bodyPr>
+          <a:lstStyle/>
+          <a:p>
+            <a:pPr algn="l">
+              <a:spcAft>
+                <a:spcPts val="200"/>
+              </a:spcAft>
+              <a:defRPr sz="1000" b="0">
+                <a:solidFill>
+                  <a:srgbClr val="667D88"/>
+                </a:solidFill>
+                <a:latin typeface="Aptos"/>
+              </a:defRPr>
+            </a:pPr>
+            <a:r>
+              <a:t>Fresh signal returns</a:t>
+            </a:r>
           </a:p>
         </p:txBody>
       </p:sp>
@@ -8146,232 +8097,25 @@
         </p:nvSpPr>
         <p:spPr>
           <a:xfrm>
-            <a:off x="804672" y="3849624"/>
-            <a:ext cx="502920" cy="365760"/>
-          </a:xfrm>
-          <a:prstGeom prst="rect">
-            <a:avLst/>
-          </a:prstGeom>
-          <a:noFill/>
-        </p:spPr>
-        <p:txBody>
-          <a:bodyPr wrap="square" lIns="0" rIns="0" tIns="0" bIns="0" anchor="ctr">
-            <a:spAutoFit/>
-          </a:bodyPr>
-          <a:lstStyle/>
-          <a:p>
-            <a:pPr algn="l">
-              <a:spcAft>
-                <a:spcPts val="200"/>
-              </a:spcAft>
-              <a:defRPr sz="2300" b="1">
-                <a:solidFill>
-                  <a:srgbClr val="167E78"/>
-                </a:solidFill>
-                <a:latin typeface="Aptos"/>
-              </a:defRPr>
-            </a:pPr>
-            <a:r>
-              <a:t>04</a:t>
-            </a:r>
-          </a:p>
-        </p:txBody>
-      </p:sp>
-      <p:sp>
-        <p:nvSpPr>
-          <p:cNvPr id="28" name="TextBox 27"/>
-          <p:cNvSpPr txBox="1"/>
-          <p:nvPr/>
-        </p:nvSpPr>
-        <p:spPr>
-          <a:xfrm>
-            <a:off x="1362456" y="3831336"/>
-            <a:ext cx="2596896" cy="338328"/>
-          </a:xfrm>
-          <a:prstGeom prst="rect">
-            <a:avLst/>
-          </a:prstGeom>
-          <a:noFill/>
-        </p:spPr>
-        <p:txBody>
-          <a:bodyPr wrap="square" lIns="0" rIns="0" tIns="0" bIns="0" anchor="ctr">
-            <a:spAutoFit/>
-          </a:bodyPr>
-          <a:lstStyle/>
-          <a:p>
-            <a:pPr algn="l">
-              <a:spcAft>
-                <a:spcPts val="200"/>
-              </a:spcAft>
-              <a:defRPr sz="1600" b="1">
-                <a:solidFill>
-                  <a:srgbClr val="172F3B"/>
-                </a:solidFill>
-                <a:latin typeface="Aptos"/>
-              </a:defRPr>
-            </a:pPr>
-            <a:r>
-              <a:t>VERIFICATION</a:t>
-            </a:r>
-          </a:p>
-        </p:txBody>
-      </p:sp>
-      <p:sp>
-        <p:nvSpPr>
-          <p:cNvPr id="29" name="TextBox 28"/>
-          <p:cNvSpPr txBox="1"/>
-          <p:nvPr/>
-        </p:nvSpPr>
-        <p:spPr>
-          <a:xfrm>
-            <a:off x="1371600" y="4261104"/>
-            <a:ext cx="2633472" cy="320040"/>
-          </a:xfrm>
-          <a:prstGeom prst="rect">
-            <a:avLst/>
-          </a:prstGeom>
-          <a:noFill/>
-        </p:spPr>
-        <p:txBody>
-          <a:bodyPr wrap="square" lIns="0" rIns="0" tIns="0" bIns="0" anchor="ctr">
-            <a:spAutoFit/>
-          </a:bodyPr>
-          <a:lstStyle/>
-          <a:p>
-            <a:pPr algn="l">
-              <a:spcAft>
-                <a:spcPts val="200"/>
-              </a:spcAft>
-              <a:defRPr sz="1300" b="0">
-                <a:solidFill>
-                  <a:srgbClr val="667D88"/>
-                </a:solidFill>
-                <a:latin typeface="Aptos"/>
-              </a:defRPr>
-            </a:pPr>
-            <a:r>
-              <a:t>Earlier forecasts resolved</a:t>
-            </a:r>
-          </a:p>
-        </p:txBody>
-      </p:sp>
-      <p:sp>
-        <p:nvSpPr>
-          <p:cNvPr id="30" name="Rounded Rectangle 29"/>
-          <p:cNvSpPr/>
-          <p:nvPr/>
-        </p:nvSpPr>
-        <p:spPr>
-          <a:xfrm>
-            <a:off x="4425696" y="3694176"/>
-            <a:ext cx="3584448" cy="1261872"/>
-          </a:xfrm>
-          <a:prstGeom prst="roundRect">
-            <a:avLst>
-              <a:gd name="adj" fmla="val 15000"/>
-            </a:avLst>
-          </a:prstGeom>
-          <a:solidFill>
-            <a:srgbClr val="FFFFFF"/>
-          </a:solidFill>
-          <a:ln w="12700">
-            <a:solidFill>
-              <a:srgbClr val="D9E4E6"/>
-            </a:solidFill>
-          </a:ln>
-        </p:spPr>
-        <p:style>
-          <a:lnRef idx="1">
-            <a:schemeClr val="accent1"/>
-          </a:lnRef>
-          <a:fillRef idx="3">
-            <a:schemeClr val="accent1"/>
-          </a:fillRef>
-          <a:effectRef idx="2">
-            <a:schemeClr val="accent1"/>
-          </a:effectRef>
-          <a:fontRef idx="minor">
-            <a:schemeClr val="lt1"/>
-          </a:fontRef>
-        </p:style>
-        <p:txBody>
-          <a:bodyPr rtlCol="0" anchor="ctr"/>
-          <a:lstStyle/>
-          <a:p>
-            <a:pPr algn="ctr"/>
-          </a:p>
-        </p:txBody>
-      </p:sp>
-      <p:sp>
-        <p:nvSpPr>
-          <p:cNvPr id="31" name="Rectangle 30"/>
-          <p:cNvSpPr/>
-          <p:nvPr/>
-        </p:nvSpPr>
-        <p:spPr>
-          <a:xfrm>
-            <a:off x="4425696" y="3694176"/>
-            <a:ext cx="50292" cy="1261872"/>
-          </a:xfrm>
-          <a:prstGeom prst="rect">
-            <a:avLst/>
-          </a:prstGeom>
-          <a:solidFill>
-            <a:srgbClr val="B46F4B"/>
-          </a:solidFill>
-          <a:ln>
-            <a:noFill/>
-          </a:ln>
-        </p:spPr>
-        <p:style>
-          <a:lnRef idx="1">
-            <a:schemeClr val="accent1"/>
-          </a:lnRef>
-          <a:fillRef idx="3">
-            <a:schemeClr val="accent1"/>
-          </a:fillRef>
-          <a:effectRef idx="2">
-            <a:schemeClr val="accent1"/>
-          </a:effectRef>
-          <a:fontRef idx="minor">
-            <a:schemeClr val="lt1"/>
-          </a:fontRef>
-        </p:style>
-        <p:txBody>
-          <a:bodyPr rtlCol="0" anchor="ctr"/>
-          <a:lstStyle/>
-          <a:p>
-            <a:pPr algn="ctr"/>
-          </a:p>
-        </p:txBody>
-      </p:sp>
-      <p:sp>
-        <p:nvSpPr>
-          <p:cNvPr id="32" name="TextBox 31"/>
-          <p:cNvSpPr txBox="1"/>
-          <p:nvPr/>
-        </p:nvSpPr>
-        <p:spPr>
-          <a:xfrm>
-            <a:off x="4626864" y="3849624"/>
-            <a:ext cx="502920" cy="365760"/>
-          </a:xfrm>
-          <a:prstGeom prst="rect">
-            <a:avLst/>
-          </a:prstGeom>
-          <a:noFill/>
-        </p:spPr>
-        <p:txBody>
-          <a:bodyPr wrap="square" lIns="0" rIns="0" tIns="0" bIns="0" anchor="ctr">
-            <a:spAutoFit/>
-          </a:bodyPr>
-          <a:lstStyle/>
-          <a:p>
-            <a:pPr algn="l">
-              <a:spcAft>
-                <a:spcPts val="200"/>
-              </a:spcAft>
-              <a:defRPr sz="2300" b="1">
+            <a:off x="8787384" y="5641848"/>
+            <a:ext cx="2542032" cy="256032"/>
+          </a:xfrm>
+          <a:prstGeom prst="rect">
+            <a:avLst/>
+          </a:prstGeom>
+          <a:noFill/>
+        </p:spPr>
+        <p:txBody>
+          <a:bodyPr wrap="square" lIns="0" rIns="0" tIns="0" bIns="0" anchor="ctr">
+            <a:spAutoFit/>
+          </a:bodyPr>
+          <a:lstStyle/>
+          <a:p>
+            <a:pPr algn="l">
+              <a:spcAft>
+                <a:spcPts val="200"/>
+              </a:spcAft>
+              <a:defRPr sz="1000" b="0">
                 <a:solidFill>
                   <a:srgbClr val="B46F4B"/>
                 </a:solidFill>
@@ -8379,415 +8123,7 @@
               </a:defRPr>
             </a:pPr>
             <a:r>
-              <a:t>05</a:t>
-            </a:r>
-          </a:p>
-        </p:txBody>
-      </p:sp>
-      <p:sp>
-        <p:nvSpPr>
-          <p:cNvPr id="33" name="TextBox 32"/>
-          <p:cNvSpPr txBox="1"/>
-          <p:nvPr/>
-        </p:nvSpPr>
-        <p:spPr>
-          <a:xfrm>
-            <a:off x="5184648" y="3831336"/>
-            <a:ext cx="2596896" cy="338328"/>
-          </a:xfrm>
-          <a:prstGeom prst="rect">
-            <a:avLst/>
-          </a:prstGeom>
-          <a:noFill/>
-        </p:spPr>
-        <p:txBody>
-          <a:bodyPr wrap="square" lIns="0" rIns="0" tIns="0" bIns="0" anchor="ctr">
-            <a:spAutoFit/>
-          </a:bodyPr>
-          <a:lstStyle/>
-          <a:p>
-            <a:pPr algn="l">
-              <a:spcAft>
-                <a:spcPts val="200"/>
-              </a:spcAft>
-              <a:defRPr sz="1600" b="1">
-                <a:solidFill>
-                  <a:srgbClr val="172F3B"/>
-                </a:solidFill>
-                <a:latin typeface="Aptos"/>
-              </a:defRPr>
-            </a:pPr>
-            <a:r>
-              <a:t>SENSOR GAP</a:t>
-            </a:r>
-          </a:p>
-        </p:txBody>
-      </p:sp>
-      <p:sp>
-        <p:nvSpPr>
-          <p:cNvPr id="34" name="TextBox 33"/>
-          <p:cNvSpPr txBox="1"/>
-          <p:nvPr/>
-        </p:nvSpPr>
-        <p:spPr>
-          <a:xfrm>
-            <a:off x="5193792" y="4261104"/>
-            <a:ext cx="2633472" cy="320040"/>
-          </a:xfrm>
-          <a:prstGeom prst="rect">
-            <a:avLst/>
-          </a:prstGeom>
-          <a:noFill/>
-        </p:spPr>
-        <p:txBody>
-          <a:bodyPr wrap="square" lIns="0" rIns="0" tIns="0" bIns="0" anchor="ctr">
-            <a:spAutoFit/>
-          </a:bodyPr>
-          <a:lstStyle/>
-          <a:p>
-            <a:pPr algn="l">
-              <a:spcAft>
-                <a:spcPts val="200"/>
-              </a:spcAft>
-              <a:defRPr sz="1300" b="0">
-                <a:solidFill>
-                  <a:srgbClr val="667D88"/>
-                </a:solidFill>
-                <a:latin typeface="Aptos"/>
-              </a:defRPr>
-            </a:pPr>
-            <a:r>
-              <a:t>Abstention, no risk</a:t>
-            </a:r>
-          </a:p>
-        </p:txBody>
-      </p:sp>
-      <p:sp>
-        <p:nvSpPr>
-          <p:cNvPr id="35" name="Rounded Rectangle 34"/>
-          <p:cNvSpPr/>
-          <p:nvPr/>
-        </p:nvSpPr>
-        <p:spPr>
-          <a:xfrm>
-            <a:off x="8247888" y="3694176"/>
-            <a:ext cx="3584448" cy="1261872"/>
-          </a:xfrm>
-          <a:prstGeom prst="roundRect">
-            <a:avLst>
-              <a:gd name="adj" fmla="val 15000"/>
-            </a:avLst>
-          </a:prstGeom>
-          <a:solidFill>
-            <a:srgbClr val="FFFFFF"/>
-          </a:solidFill>
-          <a:ln w="12700">
-            <a:solidFill>
-              <a:srgbClr val="D9E4E6"/>
-            </a:solidFill>
-          </a:ln>
-        </p:spPr>
-        <p:style>
-          <a:lnRef idx="1">
-            <a:schemeClr val="accent1"/>
-          </a:lnRef>
-          <a:fillRef idx="3">
-            <a:schemeClr val="accent1"/>
-          </a:fillRef>
-          <a:effectRef idx="2">
-            <a:schemeClr val="accent1"/>
-          </a:effectRef>
-          <a:fontRef idx="minor">
-            <a:schemeClr val="lt1"/>
-          </a:fontRef>
-        </p:style>
-        <p:txBody>
-          <a:bodyPr rtlCol="0" anchor="ctr"/>
-          <a:lstStyle/>
-          <a:p>
-            <a:pPr algn="ctr"/>
-          </a:p>
-        </p:txBody>
-      </p:sp>
-      <p:sp>
-        <p:nvSpPr>
-          <p:cNvPr id="36" name="Rectangle 35"/>
-          <p:cNvSpPr/>
-          <p:nvPr/>
-        </p:nvSpPr>
-        <p:spPr>
-          <a:xfrm>
-            <a:off x="8247888" y="3694176"/>
-            <a:ext cx="50292" cy="1261872"/>
-          </a:xfrm>
-          <a:prstGeom prst="rect">
-            <a:avLst/>
-          </a:prstGeom>
-          <a:solidFill>
-            <a:srgbClr val="167E78"/>
-          </a:solidFill>
-          <a:ln>
-            <a:noFill/>
-          </a:ln>
-        </p:spPr>
-        <p:style>
-          <a:lnRef idx="1">
-            <a:schemeClr val="accent1"/>
-          </a:lnRef>
-          <a:fillRef idx="3">
-            <a:schemeClr val="accent1"/>
-          </a:fillRef>
-          <a:effectRef idx="2">
-            <a:schemeClr val="accent1"/>
-          </a:effectRef>
-          <a:fontRef idx="minor">
-            <a:schemeClr val="lt1"/>
-          </a:fontRef>
-        </p:style>
-        <p:txBody>
-          <a:bodyPr rtlCol="0" anchor="ctr"/>
-          <a:lstStyle/>
-          <a:p>
-            <a:pPr algn="ctr"/>
-          </a:p>
-        </p:txBody>
-      </p:sp>
-      <p:sp>
-        <p:nvSpPr>
-          <p:cNvPr id="37" name="TextBox 36"/>
-          <p:cNvSpPr txBox="1"/>
-          <p:nvPr/>
-        </p:nvSpPr>
-        <p:spPr>
-          <a:xfrm>
-            <a:off x="8449056" y="3849624"/>
-            <a:ext cx="502920" cy="365760"/>
-          </a:xfrm>
-          <a:prstGeom prst="rect">
-            <a:avLst/>
-          </a:prstGeom>
-          <a:noFill/>
-        </p:spPr>
-        <p:txBody>
-          <a:bodyPr wrap="square" lIns="0" rIns="0" tIns="0" bIns="0" anchor="ctr">
-            <a:spAutoFit/>
-          </a:bodyPr>
-          <a:lstStyle/>
-          <a:p>
-            <a:pPr algn="l">
-              <a:spcAft>
-                <a:spcPts val="200"/>
-              </a:spcAft>
-              <a:defRPr sz="2300" b="1">
-                <a:solidFill>
-                  <a:srgbClr val="167E78"/>
-                </a:solidFill>
-                <a:latin typeface="Aptos"/>
-              </a:defRPr>
-            </a:pPr>
-            <a:r>
-              <a:t>06</a:t>
-            </a:r>
-          </a:p>
-        </p:txBody>
-      </p:sp>
-      <p:sp>
-        <p:nvSpPr>
-          <p:cNvPr id="38" name="TextBox 37"/>
-          <p:cNvSpPr txBox="1"/>
-          <p:nvPr/>
-        </p:nvSpPr>
-        <p:spPr>
-          <a:xfrm>
-            <a:off x="9006840" y="3831336"/>
-            <a:ext cx="2596896" cy="338328"/>
-          </a:xfrm>
-          <a:prstGeom prst="rect">
-            <a:avLst/>
-          </a:prstGeom>
-          <a:noFill/>
-        </p:spPr>
-        <p:txBody>
-          <a:bodyPr wrap="square" lIns="0" rIns="0" tIns="0" bIns="0" anchor="ctr">
-            <a:spAutoFit/>
-          </a:bodyPr>
-          <a:lstStyle/>
-          <a:p>
-            <a:pPr algn="l">
-              <a:spcAft>
-                <a:spcPts val="200"/>
-              </a:spcAft>
-              <a:defRPr sz="1600" b="1">
-                <a:solidFill>
-                  <a:srgbClr val="172F3B"/>
-                </a:solidFill>
-                <a:latin typeface="Aptos"/>
-              </a:defRPr>
-            </a:pPr>
-            <a:r>
-              <a:t>RECOVERY</a:t>
-            </a:r>
-          </a:p>
-        </p:txBody>
-      </p:sp>
-      <p:sp>
-        <p:nvSpPr>
-          <p:cNvPr id="39" name="TextBox 38"/>
-          <p:cNvSpPr txBox="1"/>
-          <p:nvPr/>
-        </p:nvSpPr>
-        <p:spPr>
-          <a:xfrm>
-            <a:off x="9015984" y="4261104"/>
-            <a:ext cx="2633472" cy="320040"/>
-          </a:xfrm>
-          <a:prstGeom prst="rect">
-            <a:avLst/>
-          </a:prstGeom>
-          <a:noFill/>
-        </p:spPr>
-        <p:txBody>
-          <a:bodyPr wrap="square" lIns="0" rIns="0" tIns="0" bIns="0" anchor="ctr">
-            <a:spAutoFit/>
-          </a:bodyPr>
-          <a:lstStyle/>
-          <a:p>
-            <a:pPr algn="l">
-              <a:spcAft>
-                <a:spcPts val="200"/>
-              </a:spcAft>
-              <a:defRPr sz="1300" b="0">
-                <a:solidFill>
-                  <a:srgbClr val="667D88"/>
-                </a:solidFill>
-                <a:latin typeface="Aptos"/>
-              </a:defRPr>
-            </a:pPr>
-            <a:r>
-              <a:t>Fresh signal returns</a:t>
-            </a:r>
-          </a:p>
-        </p:txBody>
-      </p:sp>
-      <p:sp>
-        <p:nvSpPr>
-          <p:cNvPr id="40" name="Rounded Rectangle 39"/>
-          <p:cNvSpPr/>
-          <p:nvPr/>
-        </p:nvSpPr>
-        <p:spPr>
-          <a:xfrm>
-            <a:off x="603504" y="5367528"/>
-            <a:ext cx="11219688" cy="740664"/>
-          </a:xfrm>
-          <a:prstGeom prst="roundRect">
-            <a:avLst>
-              <a:gd name="adj" fmla="val 15000"/>
-            </a:avLst>
-          </a:prstGeom>
-          <a:solidFill>
-            <a:srgbClr val="152C3C"/>
-          </a:solidFill>
-          <a:ln>
-            <a:noFill/>
-          </a:ln>
-        </p:spPr>
-        <p:style>
-          <a:lnRef idx="1">
-            <a:schemeClr val="accent1"/>
-          </a:lnRef>
-          <a:fillRef idx="3">
-            <a:schemeClr val="accent1"/>
-          </a:fillRef>
-          <a:effectRef idx="2">
-            <a:schemeClr val="accent1"/>
-          </a:effectRef>
-          <a:fontRef idx="minor">
-            <a:schemeClr val="lt1"/>
-          </a:fontRef>
-        </p:style>
-        <p:txBody>
-          <a:bodyPr rtlCol="0" anchor="ctr"/>
-          <a:lstStyle/>
-          <a:p>
-            <a:pPr algn="ctr"/>
-          </a:p>
-        </p:txBody>
-      </p:sp>
-      <p:sp>
-        <p:nvSpPr>
-          <p:cNvPr id="41" name="TextBox 40"/>
-          <p:cNvSpPr txBox="1"/>
-          <p:nvPr/>
-        </p:nvSpPr>
-        <p:spPr>
-          <a:xfrm>
-            <a:off x="832104" y="5532120"/>
-            <a:ext cx="1371600" cy="228600"/>
-          </a:xfrm>
-          <a:prstGeom prst="rect">
-            <a:avLst/>
-          </a:prstGeom>
-          <a:noFill/>
-        </p:spPr>
-        <p:txBody>
-          <a:bodyPr wrap="square" lIns="0" rIns="0" tIns="0" bIns="0" anchor="ctr">
-            <a:spAutoFit/>
-          </a:bodyPr>
-          <a:lstStyle/>
-          <a:p>
-            <a:pPr algn="l">
-              <a:spcAft>
-                <a:spcPts val="200"/>
-              </a:spcAft>
-              <a:defRPr sz="1100" b="1">
-                <a:solidFill>
-                  <a:srgbClr val="A5DCCB"/>
-                </a:solidFill>
-                <a:latin typeface="Aptos"/>
-              </a:defRPr>
-            </a:pPr>
-            <a:r>
-              <a:t>JUDGE ACTION</a:t>
-            </a:r>
-          </a:p>
-        </p:txBody>
-      </p:sp>
-      <p:sp>
-        <p:nvSpPr>
-          <p:cNvPr id="42" name="TextBox 41"/>
-          <p:cNvSpPr txBox="1"/>
-          <p:nvPr/>
-        </p:nvSpPr>
-        <p:spPr>
-          <a:xfrm>
-            <a:off x="2221992" y="5477256"/>
-            <a:ext cx="9235440" cy="365760"/>
-          </a:xfrm>
-          <a:prstGeom prst="rect">
-            <a:avLst/>
-          </a:prstGeom>
-          <a:noFill/>
-        </p:spPr>
-        <p:txBody>
-          <a:bodyPr wrap="square" lIns="0" rIns="0" tIns="0" bIns="0" anchor="ctr">
-            <a:spAutoFit/>
-          </a:bodyPr>
-          <a:lstStyle/>
-          <a:p>
-            <a:pPr algn="l">
-              <a:spcAft>
-                <a:spcPts val="200"/>
-              </a:spcAft>
-              <a:defRPr sz="1700" b="0">
-                <a:solidFill>
-                  <a:srgbClr val="FFFFFF"/>
-                </a:solidFill>
-                <a:latin typeface="Aptos"/>
-              </a:defRPr>
-            </a:pPr>
-            <a:r>
-              <a:t>Run FastAPI → open localhost:8000 → Guided judge demo → choose chapter</a:t>
+              <a:t>Six deterministic synthetic states. No clinical predictions.</a:t>
             </a:r>
           </a:p>
         </p:txBody>

</xml_diff>